<commit_message>
[Added] Certificate pdf version
</commit_message>
<xml_diff>
--- a/pptx_src/Certificate.pptx
+++ b/pptx_src/Certificate.pptx
@@ -14,7 +14,7 @@
   <p:notesSz cx="6858000" cy="9144000"/>
   <p:embeddedFontLst>
     <p:embeddedFont>
-      <p:font typeface="Slight" panose="00000500000000000000" pitchFamily="2" charset="0"/>
+      <p:font typeface="Slight" panose="020B0604020202020204" charset="0"/>
       <p:regular r:id="rId4"/>
     </p:embeddedFont>
   </p:embeddedFontLst>
@@ -214,7 +214,7 @@
           <a:p>
             <a:fld id="{5D2A3E32-B134-42CF-BF99-9DCA3D02EB99}" type="datetimeFigureOut">
               <a:rPr lang="en-US" smtClean="0"/>
-              <a:t>11/19/2025</a:t>
+              <a:t>2/23/2026</a:t>
             </a:fld>
             <a:endParaRPr lang="en-US"/>
           </a:p>
@@ -661,7 +661,7 @@
             <a:fld id="{1D8BD707-D9CF-40AE-B4C6-C98DA3205C09}" type="datetimeFigureOut">
               <a:rPr lang="en-US" smtClean="0"/>
               <a:pPr/>
-              <a:t>11/19/2025</a:t>
+              <a:t>2/23/2026</a:t>
             </a:fld>
             <a:endParaRPr lang="en-US"/>
           </a:p>
@@ -826,7 +826,7 @@
             <a:fld id="{1D8BD707-D9CF-40AE-B4C6-C98DA3205C09}" type="datetimeFigureOut">
               <a:rPr lang="en-US" smtClean="0"/>
               <a:pPr/>
-              <a:t>11/19/2025</a:t>
+              <a:t>2/23/2026</a:t>
             </a:fld>
             <a:endParaRPr lang="en-US"/>
           </a:p>
@@ -1001,7 +1001,7 @@
             <a:fld id="{1D8BD707-D9CF-40AE-B4C6-C98DA3205C09}" type="datetimeFigureOut">
               <a:rPr lang="en-US" smtClean="0"/>
               <a:pPr/>
-              <a:t>11/19/2025</a:t>
+              <a:t>2/23/2026</a:t>
             </a:fld>
             <a:endParaRPr lang="en-US"/>
           </a:p>
@@ -1166,7 +1166,7 @@
             <a:fld id="{1D8BD707-D9CF-40AE-B4C6-C98DA3205C09}" type="datetimeFigureOut">
               <a:rPr lang="en-US" smtClean="0"/>
               <a:pPr/>
-              <a:t>11/19/2025</a:t>
+              <a:t>2/23/2026</a:t>
             </a:fld>
             <a:endParaRPr lang="en-US"/>
           </a:p>
@@ -1408,7 +1408,7 @@
             <a:fld id="{1D8BD707-D9CF-40AE-B4C6-C98DA3205C09}" type="datetimeFigureOut">
               <a:rPr lang="en-US" smtClean="0"/>
               <a:pPr/>
-              <a:t>11/19/2025</a:t>
+              <a:t>2/23/2026</a:t>
             </a:fld>
             <a:endParaRPr lang="en-US"/>
           </a:p>
@@ -1690,7 +1690,7 @@
             <a:fld id="{1D8BD707-D9CF-40AE-B4C6-C98DA3205C09}" type="datetimeFigureOut">
               <a:rPr lang="en-US" smtClean="0"/>
               <a:pPr/>
-              <a:t>11/19/2025</a:t>
+              <a:t>2/23/2026</a:t>
             </a:fld>
             <a:endParaRPr lang="en-US"/>
           </a:p>
@@ -2106,7 +2106,7 @@
             <a:fld id="{1D8BD707-D9CF-40AE-B4C6-C98DA3205C09}" type="datetimeFigureOut">
               <a:rPr lang="en-US" smtClean="0"/>
               <a:pPr/>
-              <a:t>11/19/2025</a:t>
+              <a:t>2/23/2026</a:t>
             </a:fld>
             <a:endParaRPr lang="en-US"/>
           </a:p>
@@ -2220,7 +2220,7 @@
             <a:fld id="{1D8BD707-D9CF-40AE-B4C6-C98DA3205C09}" type="datetimeFigureOut">
               <a:rPr lang="en-US" smtClean="0"/>
               <a:pPr/>
-              <a:t>11/19/2025</a:t>
+              <a:t>2/23/2026</a:t>
             </a:fld>
             <a:endParaRPr lang="en-US"/>
           </a:p>
@@ -2312,7 +2312,7 @@
             <a:fld id="{1D8BD707-D9CF-40AE-B4C6-C98DA3205C09}" type="datetimeFigureOut">
               <a:rPr lang="en-US" smtClean="0"/>
               <a:pPr/>
-              <a:t>11/19/2025</a:t>
+              <a:t>2/23/2026</a:t>
             </a:fld>
             <a:endParaRPr lang="en-US"/>
           </a:p>
@@ -2584,7 +2584,7 @@
             <a:fld id="{1D8BD707-D9CF-40AE-B4C6-C98DA3205C09}" type="datetimeFigureOut">
               <a:rPr lang="en-US" smtClean="0"/>
               <a:pPr/>
-              <a:t>11/19/2025</a:t>
+              <a:t>2/23/2026</a:t>
             </a:fld>
             <a:endParaRPr lang="en-US"/>
           </a:p>
@@ -2833,7 +2833,7 @@
             <a:fld id="{1D8BD707-D9CF-40AE-B4C6-C98DA3205C09}" type="datetimeFigureOut">
               <a:rPr lang="en-US" smtClean="0"/>
               <a:pPr/>
-              <a:t>11/19/2025</a:t>
+              <a:t>2/23/2026</a:t>
             </a:fld>
             <a:endParaRPr lang="en-US"/>
           </a:p>
@@ -3041,7 +3041,7 @@
             <a:fld id="{1D8BD707-D9CF-40AE-B4C6-C98DA3205C09}" type="datetimeFigureOut">
               <a:rPr lang="en-US" smtClean="0"/>
               <a:pPr/>
-              <a:t>11/19/2025</a:t>
+              <a:t>2/23/2026</a:t>
             </a:fld>
             <a:endParaRPr lang="en-US"/>
           </a:p>
@@ -4111,11 +4111,11 @@
                   <a:effectLst/>
                   <a:latin typeface="Times New Roman" panose="02020603050405020304" pitchFamily="18" charset="0"/>
                 </a:rPr>
-                <a:t>SSBDCE202504007</a:t>
+                <a:t>SSBDCE202504020</a:t>
               </a:r>
               <a:r>
-                <a:rPr lang="en-US" dirty="0"/>
-                <a:t> </a:t>
+                <a:rPr lang="en-US" sz="2000" dirty="0"/>
+                <a:t>  </a:t>
               </a:r>
               <a:endParaRPr b="1" dirty="0">
                 <a:latin typeface="Times New Roman" panose="02020603050405020304" pitchFamily="18" charset="0"/>
@@ -4613,8 +4613,8 @@
         </p:nvSpPr>
         <p:spPr>
           <a:xfrm>
-            <a:off x="2220640" y="3097281"/>
-            <a:ext cx="5897768" cy="400110"/>
+            <a:off x="2979621" y="3097281"/>
+            <a:ext cx="5097578" cy="400110"/>
           </a:xfrm>
           <a:prstGeom prst="rect">
             <a:avLst/>
@@ -4622,44 +4622,24 @@
           <a:noFill/>
         </p:spPr>
         <p:txBody>
-          <a:bodyPr wrap="none" rtlCol="0">
+          <a:bodyPr wrap="square" rtlCol="0">
             <a:spAutoFit/>
           </a:bodyPr>
           <a:lstStyle/>
           <a:p>
             <a:r>
-              <a:rPr lang="en-US" sz="2000" b="1" i="0" u="none" strike="noStrike" dirty="0">
+              <a:rPr lang="en-US" sz="1800" b="1" i="0" u="none" strike="noStrike" dirty="0">
                 <a:solidFill>
                   <a:srgbClr val="000000"/>
                 </a:solidFill>
                 <a:effectLst/>
-                <a:latin typeface="Slight" panose="00000500000000000000" pitchFamily="2" charset="0"/>
+                <a:latin typeface="Slight" panose="020B0604020202020204" charset="0"/>
               </a:rPr>
-              <a:t>A. K. M Mahmud - </a:t>
-            </a:r>
-            <a:r>
-              <a:rPr lang="en-US" sz="2000" b="1" i="0" u="none" strike="noStrike" dirty="0" err="1">
-                <a:solidFill>
-                  <a:srgbClr val="000000"/>
-                </a:solidFill>
-                <a:effectLst/>
-                <a:latin typeface="Slight" panose="00000500000000000000" pitchFamily="2" charset="0"/>
-              </a:rPr>
-              <a:t>Ul</a:t>
-            </a:r>
-            <a:r>
-              <a:rPr lang="en-US" sz="2000" b="1" i="0" u="none" strike="noStrike" dirty="0">
-                <a:solidFill>
-                  <a:srgbClr val="000000"/>
-                </a:solidFill>
-                <a:effectLst/>
-                <a:latin typeface="Slight" panose="00000500000000000000" pitchFamily="2" charset="0"/>
-              </a:rPr>
-              <a:t> - Hasan</a:t>
+              <a:t>Araf Bin Islam Swapnil</a:t>
             </a:r>
             <a:r>
               <a:rPr lang="en-US" sz="2000" dirty="0">
-                <a:latin typeface="Slight" panose="00000500000000000000" pitchFamily="2" charset="0"/>
+                <a:latin typeface="Slight" panose="020B0604020202020204" charset="0"/>
               </a:rPr>
               <a:t> </a:t>
             </a:r>

</xml_diff>